<commit_message>
Apply workshops: Development D6 (W01–W06); rebuild all 72 workshops with the final template
Co-Authored-By: Claude Opus 5.5 <noreply@anthropic.com>
Claude-Session: https://claude.ai/code/session_01QWUKnGV7MRCnE8883pixoX
</commit_message>
<xml_diff>
--- a/Foundation_F1/Workshop/F1-W01_Apply_Workshop_L01-L02_Our_Class_Word_Wall.pptx
+++ b/Foundation_F1/Workshop/F1-W01_Apply_Workshop_L01-L02_Our_Class_Word_Wall.pptx
@@ -4285,7 +4285,7 @@
                 <a:latin typeface="Calibri" pitchFamily="34" charset="0"/>
                 <a:cs typeface="Amiri" pitchFamily="2" charset="-78"/>
               </a:rPr>
-              <a:t>What is this letter? (points to </a:t>
+              <a:t>What is this letter? (points to ‏</a:t>
             </a:r>
             <a:pPr algn="l" indent="0" marL="0">
               <a:buNone/>
@@ -4312,7 +4312,7 @@
                 <a:latin typeface="Calibri" pitchFamily="34" charset="0"/>
                 <a:cs typeface="Amiri" pitchFamily="2" charset="-78"/>
               </a:rPr>
-              <a:t>)</a:t>
+              <a:t>‏)</a:t>
             </a:r>
             <a:endParaRPr lang="en-US" sz="1100" dirty="0"/>
           </a:p>
@@ -4596,7 +4596,7 @@
                 <a:latin typeface="Calibri" pitchFamily="34" charset="0"/>
                 <a:cs typeface="Amiri" pitchFamily="2" charset="-78"/>
               </a:rPr>
-              <a:t>And this? (points to </a:t>
+              <a:t>And this? (points to ‏</a:t>
             </a:r>
             <a:pPr algn="l" indent="0" marL="0">
               <a:buNone/>
@@ -4623,7 +4623,7 @@
                 <a:latin typeface="Calibri" pitchFamily="34" charset="0"/>
                 <a:cs typeface="Amiri" pitchFamily="2" charset="-78"/>
               </a:rPr>
-              <a:t>)</a:t>
+              <a:t>‏)</a:t>
             </a:r>
             <a:endParaRPr lang="en-US" sz="1100" dirty="0"/>
           </a:p>
@@ -9243,7 +9243,7 @@
                 <a:latin typeface="Calibri" pitchFamily="34" charset="0"/>
                 <a:cs typeface="Amiri" pitchFamily="2" charset="-78"/>
               </a:rPr>
-              <a:t>Point to the letter that is NOT in the </a:t>
+              <a:t>Point to the letter that is NOT in the ‏</a:t>
             </a:r>
             <a:pPr algn="l" indent="0" marL="0">
               <a:buNone/>
@@ -9270,7 +9270,7 @@
                 <a:latin typeface="Calibri" pitchFamily="34" charset="0"/>
                 <a:cs typeface="Amiri" pitchFamily="2" charset="-78"/>
               </a:rPr>
-              <a:t> family.</a:t>
+              <a:t>‏ family.</a:t>
             </a:r>
             <a:endParaRPr lang="en-US" sz="1100" dirty="0"/>
           </a:p>
@@ -17244,6 +17244,19 @@
               <a:buNone/>
             </a:pPr>
             <a:r>
+              <a:rPr lang="en-US" sz="1150" b="1" dirty="0">
+                <a:solidFill>
+                  <a:srgbClr val="1B3B6F"/>
+                </a:solidFill>
+                <a:latin typeface="Calibri" pitchFamily="34" charset="0"/>
+                <a:cs typeface="Amiri" pitchFamily="2" charset="-78"/>
+              </a:rPr>
+              <a:t>‏</a:t>
+            </a:r>
+            <a:pPr algn="l" indent="0" marL="0">
+              <a:buNone/>
+            </a:pPr>
+            <a:r>
               <a:rPr lang="ar-SA" altLang="en-US" sz="1500" b="1" dirty="0">
                 <a:solidFill>
                   <a:srgbClr val="1B3B6F"/>
@@ -17265,7 +17278,7 @@
                 <a:latin typeface="Calibri" pitchFamily="34" charset="0"/>
                 <a:cs typeface="Amiri" pitchFamily="2" charset="-78"/>
               </a:rPr>
-              <a:t> = one dot below; </a:t>
+              <a:t>‏ = one dot below; ‏</a:t>
             </a:r>
             <a:pPr algn="l" indent="0" marL="0">
               <a:buNone/>
@@ -17292,7 +17305,7 @@
                 <a:latin typeface="Calibri" pitchFamily="34" charset="0"/>
                 <a:cs typeface="Amiri" pitchFamily="2" charset="-78"/>
               </a:rPr>
-              <a:t> = two dots above.</a:t>
+              <a:t>‏ = two dots above.</a:t>
             </a:r>
             <a:endParaRPr lang="en-US" sz="1150" dirty="0"/>
           </a:p>
@@ -17496,6 +17509,19 @@
               <a:buNone/>
             </a:pPr>
             <a:r>
+              <a:rPr lang="en-US" sz="1150" b="1" dirty="0">
+                <a:solidFill>
+                  <a:srgbClr val="1B3B6F"/>
+                </a:solidFill>
+                <a:latin typeface="Calibri" pitchFamily="34" charset="0"/>
+                <a:cs typeface="Amiri" pitchFamily="2" charset="-78"/>
+              </a:rPr>
+              <a:t>‏</a:t>
+            </a:r>
+            <a:pPr algn="l" indent="0" marL="0">
+              <a:buNone/>
+            </a:pPr>
+            <a:r>
               <a:rPr lang="ar-SA" altLang="en-US" sz="1500" b="1" dirty="0">
                 <a:solidFill>
                   <a:srgbClr val="1B3B6F"/>
@@ -17517,7 +17543,7 @@
                 <a:latin typeface="Calibri" pitchFamily="34" charset="0"/>
                 <a:cs typeface="Amiri" pitchFamily="2" charset="-78"/>
               </a:rPr>
-              <a:t> has no dots; </a:t>
+              <a:t>‏ has no dots; ‏</a:t>
             </a:r>
             <a:pPr algn="l" indent="0" marL="0">
               <a:buNone/>
@@ -17544,7 +17570,7 @@
                 <a:latin typeface="Calibri" pitchFamily="34" charset="0"/>
                 <a:cs typeface="Amiri" pitchFamily="2" charset="-78"/>
               </a:rPr>
-              <a:t> has three.</a:t>
+              <a:t>‏ has three.</a:t>
             </a:r>
             <a:endParaRPr lang="en-US" sz="1150" dirty="0"/>
           </a:p>
@@ -17748,6 +17774,19 @@
               <a:buNone/>
             </a:pPr>
             <a:r>
+              <a:rPr lang="en-US" sz="1150" b="1" dirty="0">
+                <a:solidFill>
+                  <a:srgbClr val="1B3B6F"/>
+                </a:solidFill>
+                <a:latin typeface="Calibri" pitchFamily="34" charset="0"/>
+                <a:cs typeface="Amiri" pitchFamily="2" charset="-78"/>
+              </a:rPr>
+              <a:t>‏</a:t>
+            </a:r>
+            <a:pPr algn="l" indent="0" marL="0">
+              <a:buNone/>
+            </a:pPr>
+            <a:r>
               <a:rPr lang="ar-SA" altLang="en-US" sz="1500" b="1" dirty="0">
                 <a:solidFill>
                   <a:srgbClr val="1B3B6F"/>
@@ -17769,7 +17808,7 @@
                 <a:latin typeface="Calibri" pitchFamily="34" charset="0"/>
                 <a:cs typeface="Amiri" pitchFamily="2" charset="-78"/>
               </a:rPr>
-              <a:t> has its dot ABOVE; </a:t>
+              <a:t>‏ has its dot ABOVE; ‏</a:t>
             </a:r>
             <a:pPr algn="l" indent="0" marL="0">
               <a:buNone/>
@@ -17796,7 +17835,7 @@
                 <a:latin typeface="Calibri" pitchFamily="34" charset="0"/>
                 <a:cs typeface="Amiri" pitchFamily="2" charset="-78"/>
               </a:rPr>
-              <a:t> has it below.</a:t>
+              <a:t>‏ has it below.</a:t>
             </a:r>
             <a:endParaRPr lang="en-US" sz="1150" dirty="0"/>
           </a:p>
@@ -23390,7 +23429,7 @@
                 <a:latin typeface="Calibri" pitchFamily="34" charset="0"/>
                 <a:cs typeface="Amiri" pitchFamily="2" charset="-78"/>
               </a:rPr>
-              <a:t>join letters correctly — and leave a gap after </a:t>
+              <a:t>join letters correctly — and leave a gap after ‏</a:t>
             </a:r>
             <a:pPr algn="l" indent="0" marL="0">
               <a:buNone/>
@@ -23417,7 +23456,7 @@
                 <a:latin typeface="Calibri" pitchFamily="34" charset="0"/>
                 <a:cs typeface="Amiri" pitchFamily="2" charset="-78"/>
               </a:rPr>
-              <a:t>?</a:t>
+              <a:t>‏?</a:t>
             </a:r>
             <a:endParaRPr lang="en-US" sz="1100" dirty="0"/>
           </a:p>

</xml_diff>